<commit_message>
Add turn and game clocks to X-ray Blackjack
30 s per turn (timeout = that team STANDS) and a 3:00 game clock (end =
both teams STAND). Adds Pause (P), toast messages, clock display, a sixth
rule on the Rules screen, and updates deck, script and checklist timing.

Co-Authored-By: Claude Sonnet 5.5 <noreply@anthropic.com>
</commit_message>
<xml_diff>
--- a/DR_Overview.pptx
+++ b/DR_Overview.pptx
@@ -782,7 +782,7 @@
           <a:p>
             <a:r>
               <a:rPr lang="en-US" dirty="0"/>
-              <a:t>D hosts; A clicks cards, B referees, C collects Team Left votes. Split the room into Team Left and Team Right, each with a captain. Both teams start from the same grainy image; the ideal image is always on screen. Each round, a team plays a multiplier card on its own exposure; the new image appears for both teams, so they compare. The first team's card is blocked for the second team that round. First pick alternates (the Random button decides round 1). Up to 4 rounds or STAND; a team that stands is out, but the other team keeps playing all its remaining rounds, so standing early gives no advantage. The last image is the submission. Score = Quality x 2 minus Dose; quality is hidden until the reveal, dose is the bar. About 25 s per round. Then press Reveal and hand to slide 12.</a:t>
+              <a:t>D hosts; A clicks cards, B referees, C collects Team Left votes. Split the room into Team Left and Team Right, each with a captain. Both teams start from the same grainy image; the ideal image is always on screen. Each round, a team plays a multiplier card on its own exposure; the new image appears for both teams, so they compare. The first team's card is blocked for the second team that round. First pick alternates (the Random button decides round 1). Clocks: 30 seconds per turn (timeout means that team stands) and 3 minutes for the whole game (when it ends both teams stand). Up to 4 rounds or STAND; a team that stands is out, but the other team keeps playing all its remaining rounds, so standing early gives no advantage. The last image is the submission. Score = Quality x 2 minus Dose; quality is hidden until the reveal, dose is the bar. About 25 s per round. Then press Reveal and hand to slide 12.</a:t>
             </a:r>
             <a:endParaRPr lang="en-US" dirty="0"/>
           </a:p>
@@ -3495,7 +3495,7 @@
                 <a:ea typeface="Calibri" pitchFamily="34" charset="-122"/>
                 <a:cs typeface="Calibri" pitchFamily="34" charset="-120"/>
               </a:rPr>
-              <a:t>ACTIVITY 2  ·  2.5 min</a:t>
+              <a:t>ACTIVITY 2  ·  3 min</a:t>
             </a:r>
             <a:endParaRPr lang="en-US" sz="1600" dirty="0"/>
           </a:p>
@@ -3504,6 +3504,53 @@
       <p:sp>
         <p:nvSpPr>
           <p:cNvPr id="7" name="Text 4"/>
+          <p:cNvSpPr txBox="1"/>
+          <p:nvPr/>
+        </p:nvSpPr>
+        <p:spPr>
+          <a:xfrm>
+            <a:off x="3063240" y="1188720"/>
+            <a:ext cx="2880360" cy="502920"/>
+          </a:xfrm>
+          <a:prstGeom prst="roundRect">
+            <a:avLst>
+              <a:gd name="adj" fmla="val 14545"/>
+            </a:avLst>
+          </a:prstGeom>
+          <a:solidFill>
+            <a:srgbClr val="EAF1F8"/>
+          </a:solidFill>
+          <a:ln w="6350">
+            <a:solidFill>
+              <a:srgbClr val="EAF1F8"/>
+            </a:solidFill>
+          </a:ln>
+        </p:spPr>
+        <p:txBody>
+          <a:bodyPr wrap="square" lIns="76200" tIns="76200" rIns="76200" bIns="76200" rtlCol="0" anchor="ctr"/>
+          <a:lstStyle/>
+          <a:p>
+            <a:pPr algn="ctr" indent="0" marL="0">
+              <a:buNone/>
+            </a:pPr>
+            <a:r>
+              <a:rPr lang="en-US" sz="1600" b="1" dirty="0">
+                <a:solidFill>
+                  <a:srgbClr val="14325C"/>
+                </a:solidFill>
+                <a:latin typeface="Calibri" pitchFamily="34" charset="0"/>
+                <a:ea typeface="Calibri" pitchFamily="34" charset="-122"/>
+                <a:cs typeface="Calibri" pitchFamily="34" charset="-120"/>
+              </a:rPr>
+              <a:t>30 s per turn · 3:00 total</a:t>
+            </a:r>
+            <a:endParaRPr lang="en-US" sz="1600" dirty="0"/>
+          </a:p>
+        </p:txBody>
+      </p:sp>
+      <p:sp>
+        <p:nvSpPr>
+          <p:cNvPr id="8" name="Text 5"/>
           <p:cNvSpPr txBox="1"/>
           <p:nvPr/>
         </p:nvSpPr>
@@ -3548,7 +3595,7 @@
       </p:sp>
       <p:sp>
         <p:nvSpPr>
-          <p:cNvPr id="8" name="Text 5"/>
+          <p:cNvPr id="9" name="Text 6"/>
           <p:cNvSpPr txBox="1"/>
           <p:nvPr/>
         </p:nvSpPr>
@@ -3587,7 +3634,7 @@
       </p:sp>
       <p:sp>
         <p:nvSpPr>
-          <p:cNvPr id="9" name="Text 6"/>
+          <p:cNvPr id="10" name="Text 7"/>
           <p:cNvSpPr txBox="1"/>
           <p:nvPr/>
         </p:nvSpPr>
@@ -3632,7 +3679,7 @@
       </p:sp>
       <p:sp>
         <p:nvSpPr>
-          <p:cNvPr id="10" name="Text 7"/>
+          <p:cNvPr id="11" name="Text 8"/>
           <p:cNvSpPr txBox="1"/>
           <p:nvPr/>
         </p:nvSpPr>
@@ -3671,7 +3718,7 @@
       </p:sp>
       <p:sp>
         <p:nvSpPr>
-          <p:cNvPr id="11" name="Text 8"/>
+          <p:cNvPr id="12" name="Text 9"/>
           <p:cNvSpPr txBox="1"/>
           <p:nvPr/>
         </p:nvSpPr>
@@ -3716,7 +3763,7 @@
       </p:sp>
       <p:sp>
         <p:nvSpPr>
-          <p:cNvPr id="12" name="Text 9"/>
+          <p:cNvPr id="13" name="Text 10"/>
           <p:cNvSpPr txBox="1"/>
           <p:nvPr/>
         </p:nvSpPr>
@@ -3755,7 +3802,7 @@
       </p:sp>
       <p:sp>
         <p:nvSpPr>
-          <p:cNvPr id="13" name="Text 10"/>
+          <p:cNvPr id="14" name="Text 11"/>
           <p:cNvSpPr txBox="1"/>
           <p:nvPr/>
         </p:nvSpPr>
@@ -3800,7 +3847,7 @@
       </p:sp>
       <p:sp>
         <p:nvSpPr>
-          <p:cNvPr id="14" name="Text 11"/>
+          <p:cNvPr id="15" name="Text 12"/>
           <p:cNvSpPr txBox="1"/>
           <p:nvPr/>
         </p:nvSpPr>
@@ -3831,7 +3878,7 @@
                 <a:ea typeface="Calibri" pitchFamily="34" charset="-122"/>
                 <a:cs typeface="Calibri" pitchFamily="34" charset="-120"/>
               </a:rPr>
-              <a:t>Up to 4 rounds, or STAND. The other team keeps playing. Last image counts.</a:t>
+              <a:t>Up to 4 rounds, or STAND (timeout = STAND). Last image counts.</a:t>
             </a:r>
             <a:endParaRPr lang="en-US" sz="1800" dirty="0"/>
           </a:p>
@@ -3839,7 +3886,7 @@
       </p:sp>
       <p:sp>
         <p:nvSpPr>
-          <p:cNvPr id="15" name="Text 12"/>
+          <p:cNvPr id="16" name="Text 13"/>
           <p:cNvSpPr txBox="1"/>
           <p:nvPr/>
         </p:nvSpPr>
@@ -3886,7 +3933,7 @@
       </p:sp>
       <p:pic>
         <p:nvPicPr>
-          <p:cNvPr id="16" name="Image 0" descr="D:\Lectures\Diagnostic Imaging\Homework_1\topic1\_build\fig\start.png">    </p:cNvPr>
+          <p:cNvPr id="17" name="Image 0" descr="D:\Lectures\Diagnostic Imaging\Homework_1\topic1\_build\fig\start.png">    </p:cNvPr>
           <p:cNvPicPr>
             <a:picLocks noChangeAspect="1"/>
           </p:cNvPicPr>
@@ -3910,7 +3957,7 @@
       </p:pic>
       <p:sp>
         <p:nvSpPr>
-          <p:cNvPr id="17" name="Shape 13"/>
+          <p:cNvPr id="18" name="Shape 14"/>
           <p:cNvSpPr/>
           <p:nvPr/>
         </p:nvSpPr>
@@ -3934,7 +3981,7 @@
       </p:sp>
       <p:pic>
         <p:nvPicPr>
-          <p:cNvPr id="18" name="Image 1" descr="D:\Lectures\Diagnostic Imaging\Homework_1\topic1\_build\fig\ideal.png">    </p:cNvPr>
+          <p:cNvPr id="19" name="Image 1" descr="D:\Lectures\Diagnostic Imaging\Homework_1\topic1\_build\fig\ideal.png">    </p:cNvPr>
           <p:cNvPicPr>
             <a:picLocks noChangeAspect="1"/>
           </p:cNvPicPr>
@@ -3958,7 +4005,7 @@
       </p:pic>
       <p:sp>
         <p:nvSpPr>
-          <p:cNvPr id="19" name="Text 14"/>
+          <p:cNvPr id="20" name="Text 15"/>
           <p:cNvSpPr txBox="1"/>
           <p:nvPr/>
         </p:nvSpPr>
@@ -3997,7 +4044,7 @@
       </p:sp>
       <p:sp>
         <p:nvSpPr>
-          <p:cNvPr id="20" name="Text 15"/>
+          <p:cNvPr id="21" name="Text 16"/>
           <p:cNvSpPr txBox="1"/>
           <p:nvPr/>
         </p:nvSpPr>
@@ -4036,7 +4083,7 @@
       </p:sp>
       <p:sp>
         <p:nvSpPr>
-          <p:cNvPr id="21" name="Text 16"/>
+          <p:cNvPr id="22" name="Text 17"/>
           <p:cNvSpPr txBox="1"/>
           <p:nvPr/>
         </p:nvSpPr>
@@ -4083,7 +4130,7 @@
       </p:sp>
       <p:sp>
         <p:nvSpPr>
-          <p:cNvPr id="22" name="Text 17"/>
+          <p:cNvPr id="23" name="Text 18"/>
           <p:cNvSpPr txBox="1"/>
           <p:nvPr/>
         </p:nvSpPr>
@@ -4130,7 +4177,7 @@
       </p:sp>
       <p:sp>
         <p:nvSpPr>
-          <p:cNvPr id="23" name="Text 18"/>
+          <p:cNvPr id="24" name="Text 19"/>
           <p:cNvSpPr txBox="1"/>
           <p:nvPr/>
         </p:nvSpPr>
@@ -4177,7 +4224,7 @@
       </p:sp>
       <p:sp>
         <p:nvSpPr>
-          <p:cNvPr id="24" name="Text 19"/>
+          <p:cNvPr id="25" name="Text 20"/>
           <p:cNvSpPr txBox="1"/>
           <p:nvPr/>
         </p:nvSpPr>
@@ -4224,7 +4271,7 @@
       </p:sp>
       <p:sp>
         <p:nvSpPr>
-          <p:cNvPr id="25" name="Text 20"/>
+          <p:cNvPr id="26" name="Text 21"/>
           <p:cNvSpPr txBox="1"/>
           <p:nvPr/>
         </p:nvSpPr>
@@ -4271,7 +4318,7 @@
       </p:sp>
       <p:sp>
         <p:nvSpPr>
-          <p:cNvPr id="26" name="Text 21"/>
+          <p:cNvPr id="27" name="Text 22"/>
           <p:cNvSpPr txBox="1"/>
           <p:nvPr/>
         </p:nvSpPr>
@@ -4318,7 +4365,7 @@
       </p:sp>
       <p:sp>
         <p:nvSpPr>
-          <p:cNvPr id="27" name="Text 22"/>
+          <p:cNvPr id="28" name="Text 23"/>
           <p:cNvSpPr txBox="1"/>
           <p:nvPr/>
         </p:nvSpPr>
@@ -4365,7 +4412,7 @@
       </p:sp>
       <p:sp>
         <p:nvSpPr>
-          <p:cNvPr id="28" name="Text 23"/>
+          <p:cNvPr id="29" name="Text 24"/>
           <p:cNvSpPr txBox="1"/>
           <p:nvPr/>
         </p:nvSpPr>
@@ -4412,7 +4459,7 @@
       </p:sp>
       <p:sp>
         <p:nvSpPr>
-          <p:cNvPr id="29" name="Text 24"/>
+          <p:cNvPr id="30" name="Text 25"/>
           <p:cNvSpPr txBox="1"/>
           <p:nvPr/>
         </p:nvSpPr>
@@ -4451,7 +4498,7 @@
       </p:sp>
       <p:sp>
         <p:nvSpPr>
-          <p:cNvPr id="30" name="Shape 25"/>
+          <p:cNvPr id="31" name="Shape 26"/>
           <p:cNvSpPr/>
           <p:nvPr/>
         </p:nvSpPr>
@@ -4476,7 +4523,7 @@
       </p:sp>
       <p:sp>
         <p:nvSpPr>
-          <p:cNvPr id="31" name="Shape 26"/>
+          <p:cNvPr id="32" name="Shape 27"/>
           <p:cNvSpPr/>
           <p:nvPr/>
         </p:nvSpPr>
@@ -4501,7 +4548,7 @@
       </p:sp>
       <p:sp>
         <p:nvSpPr>
-          <p:cNvPr id="32" name="Shape 27"/>
+          <p:cNvPr id="33" name="Shape 28"/>
           <p:cNvSpPr/>
           <p:nvPr/>
         </p:nvSpPr>
@@ -4526,7 +4573,7 @@
       </p:sp>
       <p:sp>
         <p:nvSpPr>
-          <p:cNvPr id="33" name="Text 28"/>
+          <p:cNvPr id="34" name="Text 29"/>
           <p:cNvSpPr txBox="1"/>
           <p:nvPr/>
         </p:nvSpPr>

</xml_diff>

<commit_message>
Blackjack: cards multiply the initial scan; two-row history with multipliers
Cards are now x2..x40 of the INITIAL exposure (each card is a fresh scan),
replacing the dead fractional cards; x15 and x40 add invisible overexposure.
History shows two rows with the chosen multiplier under each image. Adds a
diagram on the Rules screen and slide 11; engine tests, guide, script and
checklist updated.

Co-Authored-By: Claude Sonnet 5.5 <noreply@anthropic.com>
</commit_message>
<xml_diff>
--- a/DR_Overview.pptx
+++ b/DR_Overview.pptx
@@ -782,7 +782,7 @@
           <a:p>
             <a:r>
               <a:rPr lang="en-US" dirty="0"/>
-              <a:t>D hosts; A clicks cards, B referees, C collects Team Left votes. Split the room into Team Left and Team Right, each with a captain. Both teams start from the same grainy image; the ideal image is always on screen. Each round, a team plays a multiplier card on its own exposure; the new image appears for both teams, so they compare. The first team's card is blocked for the second team that round. First pick alternates (the Random button decides round 1). Clocks: 30 seconds per turn (timeout means that team stands) and 3 minutes for the whole game (when it ends both teams stand). Up to 4 rounds or STAND; a team that stands is out, but the other team keeps playing all its remaining rounds, so standing early gives no advantage. The last image is the submission. Score = Quality x 2 minus Dose; quality is hidden until the reveal, dose is the bar. About 25 s per round. Then press Reveal and hand to slide 12.</a:t>
+              <a:t>D hosts; A clicks cards, B referees, C collects Team Left votes. Split the room into Team Left and Team Right, each with a captain. Both teams start from the same grainy image; the ideal image is always on screen. Each round, a team plays a multiplier card; the new scan is the INITIAL exposure times the card (not the last scan times the card), so every card is a fresh scan and more dose. The new image appears for both teams, so they compare. Cards: x2 to x6 are still grainy, x8 and x10 land at about the ideal, x15 is wasteful overexposure that looks identical, x40 looks fine but blows the dose limit. The first team's card is blocked for the second team that round. First pick alternates (the Random button decides round 1). Clocks: 30 seconds per turn (timeout means that team stands) and 3 minutes for the whole game (when it ends both teams stand). Up to 4 rounds or STAND; a team that stands is out, but the other team keeps playing all its remaining rounds, so standing early gives no advantage. The last image is the submission. Score = Quality x 2 minus Dose; quality is hidden until the reveal, dose is the bar. About 25 s per round. Then press Reveal and hand to slide 12.</a:t>
             </a:r>
             <a:endParaRPr lang="en-US" dirty="0"/>
           </a:p>
@@ -3710,7 +3710,7 @@
                 <a:ea typeface="Calibri" pitchFamily="34" charset="-122"/>
                 <a:cs typeface="Calibri" pitchFamily="34" charset="-120"/>
               </a:rPr>
-              <a:t>Each round: play a × card on your own exposure. New image, more dose.</a:t>
+              <a:t>Each round: play a × card. New scan = initial × card, not last scan × card.</a:t>
             </a:r>
             <a:endParaRPr lang="en-US" sz="1800" dirty="0"/>
           </a:p>
@@ -4122,7 +4122,7 @@
                 <a:ea typeface="Calibri" pitchFamily="34" charset="-122"/>
                 <a:cs typeface="Calibri" pitchFamily="34" charset="-120"/>
               </a:rPr>
-              <a:t>×⅙</a:t>
+              <a:t>×2</a:t>
             </a:r>
             <a:endParaRPr lang="en-US" sz="1800" dirty="0"/>
           </a:p>
@@ -4169,7 +4169,7 @@
                 <a:ea typeface="Calibri" pitchFamily="34" charset="-122"/>
                 <a:cs typeface="Calibri" pitchFamily="34" charset="-120"/>
               </a:rPr>
-              <a:t>×¼</a:t>
+              <a:t>×3</a:t>
             </a:r>
             <a:endParaRPr lang="en-US" sz="1800" dirty="0"/>
           </a:p>
@@ -4216,7 +4216,7 @@
                 <a:ea typeface="Calibri" pitchFamily="34" charset="-122"/>
                 <a:cs typeface="Calibri" pitchFamily="34" charset="-120"/>
               </a:rPr>
-              <a:t>×⅓</a:t>
+              <a:t>×4</a:t>
             </a:r>
             <a:endParaRPr lang="en-US" sz="1800" dirty="0"/>
           </a:p>
@@ -4263,7 +4263,7 @@
                 <a:ea typeface="Calibri" pitchFamily="34" charset="-122"/>
                 <a:cs typeface="Calibri" pitchFamily="34" charset="-120"/>
               </a:rPr>
-              <a:t>×½</a:t>
+              <a:t>×6</a:t>
             </a:r>
             <a:endParaRPr lang="en-US" sz="1800" dirty="0"/>
           </a:p>
@@ -4310,7 +4310,7 @@
                 <a:ea typeface="Calibri" pitchFamily="34" charset="-122"/>
                 <a:cs typeface="Calibri" pitchFamily="34" charset="-120"/>
               </a:rPr>
-              <a:t>×2</a:t>
+              <a:t>×8</a:t>
             </a:r>
             <a:endParaRPr lang="en-US" sz="1800" dirty="0"/>
           </a:p>
@@ -4357,7 +4357,7 @@
                 <a:ea typeface="Calibri" pitchFamily="34" charset="-122"/>
                 <a:cs typeface="Calibri" pitchFamily="34" charset="-120"/>
               </a:rPr>
-              <a:t>×3</a:t>
+              <a:t>×10</a:t>
             </a:r>
             <a:endParaRPr lang="en-US" sz="1800" dirty="0"/>
           </a:p>
@@ -4404,7 +4404,7 @@
                 <a:ea typeface="Calibri" pitchFamily="34" charset="-122"/>
                 <a:cs typeface="Calibri" pitchFamily="34" charset="-120"/>
               </a:rPr>
-              <a:t>×4</a:t>
+              <a:t>×15</a:t>
             </a:r>
             <a:endParaRPr lang="en-US" sz="1800" dirty="0"/>
           </a:p>
@@ -4451,7 +4451,7 @@
                 <a:ea typeface="Calibri" pitchFamily="34" charset="-122"/>
                 <a:cs typeface="Calibri" pitchFamily="34" charset="-120"/>
               </a:rPr>
-              <a:t>×6</a:t>
+              <a:t>×40</a:t>
             </a:r>
             <a:endParaRPr lang="en-US" sz="1800" dirty="0"/>
           </a:p>
@@ -4465,8 +4465,8 @@
         </p:nvSpPr>
         <p:spPr>
           <a:xfrm>
-            <a:off x="6400800" y="5029200"/>
-            <a:ext cx="2743200" cy="320040"/>
+            <a:off x="6400800" y="4983480"/>
+            <a:ext cx="5303520" cy="320040"/>
           </a:xfrm>
           <a:prstGeom prst="rect">
             <a:avLst/>
@@ -4482,7 +4482,46 @@
               <a:buNone/>
             </a:pPr>
             <a:r>
-              <a:rPr lang="en-US" sz="1500" dirty="0">
+              <a:rPr lang="en-US" sz="1500" b="1" dirty="0">
+                <a:solidFill>
+                  <a:srgbClr val="14325C"/>
+                </a:solidFill>
+                <a:latin typeface="Calibri" pitchFamily="34" charset="0"/>
+                <a:ea typeface="Calibri" pitchFamily="34" charset="-122"/>
+                <a:cs typeface="Calibri" pitchFamily="34" charset="-120"/>
+              </a:rPr>
+              <a:t>Cards multiply the INITIAL scan, not your last scan</a:t>
+            </a:r>
+            <a:endParaRPr lang="en-US" sz="1500" dirty="0"/>
+          </a:p>
+        </p:txBody>
+      </p:sp>
+      <p:sp>
+        <p:nvSpPr>
+          <p:cNvPr id="31" name="Text 26"/>
+          <p:cNvSpPr txBox="1"/>
+          <p:nvPr/>
+        </p:nvSpPr>
+        <p:spPr>
+          <a:xfrm>
+            <a:off x="6400800" y="5321808"/>
+            <a:ext cx="1188720" cy="274320"/>
+          </a:xfrm>
+          <a:prstGeom prst="rect">
+            <a:avLst/>
+          </a:prstGeom>
+          <a:noFill/>
+          <a:ln/>
+        </p:spPr>
+        <p:txBody>
+          <a:bodyPr wrap="square" lIns="0" tIns="0" rIns="0" bIns="0" rtlCol="0" anchor="ctr"/>
+          <a:lstStyle/>
+          <a:p>
+            <a:pPr algn="l" indent="0" marL="0">
+              <a:buNone/>
+            </a:pPr>
+            <a:r>
+              <a:rPr lang="en-US" sz="1400" dirty="0">
                 <a:solidFill>
                   <a:srgbClr val="5A6B7D"/>
                 </a:solidFill>
@@ -4490,36 +4529,11 @@
                 <a:ea typeface="Calibri" pitchFamily="34" charset="-122"/>
                 <a:cs typeface="Calibri" pitchFamily="34" charset="-120"/>
               </a:rPr>
-              <a:t>Dose bar (relative):</a:t>
-            </a:r>
-            <a:endParaRPr lang="en-US" sz="1500" dirty="0"/>
-          </a:p>
-        </p:txBody>
-      </p:sp>
-      <p:sp>
-        <p:nvSpPr>
-          <p:cNvPr id="31" name="Shape 26"/>
-          <p:cNvSpPr/>
-          <p:nvPr/>
-        </p:nvSpPr>
-        <p:spPr>
-          <a:xfrm>
-            <a:off x="6400800" y="5440680"/>
-            <a:ext cx="1737360" cy="365760"/>
-          </a:xfrm>
-          <a:prstGeom prst="rect">
-            <a:avLst/>
-          </a:prstGeom>
-          <a:solidFill>
-            <a:srgbClr val="3FBF6B"/>
-          </a:solidFill>
-          <a:ln w="6350">
-            <a:solidFill>
-              <a:srgbClr val="3FBF6B"/>
-            </a:solidFill>
-            <a:prstDash val="solid"/>
-          </a:ln>
-        </p:spPr>
+              <a:t>initial</a:t>
+            </a:r>
+            <a:endParaRPr lang="en-US" sz="1400" dirty="0"/>
+          </a:p>
+        </p:txBody>
       </p:sp>
       <p:sp>
         <p:nvSpPr>
@@ -4529,8 +4543,8 @@
         </p:nvSpPr>
         <p:spPr>
           <a:xfrm>
-            <a:off x="8138160" y="5440680"/>
-            <a:ext cx="1737360" cy="365760"/>
+            <a:off x="7635240" y="5349240"/>
+            <a:ext cx="146304" cy="219456"/>
           </a:xfrm>
           <a:prstGeom prst="rect">
             <a:avLst/>
@@ -4548,24 +4562,102 @@
       </p:sp>
       <p:sp>
         <p:nvSpPr>
-          <p:cNvPr id="33" name="Shape 28"/>
+          <p:cNvPr id="33" name="Text 28"/>
+          <p:cNvSpPr txBox="1"/>
+          <p:nvPr/>
+        </p:nvSpPr>
+        <p:spPr>
+          <a:xfrm>
+            <a:off x="7891272" y="5321808"/>
+            <a:ext cx="2926080" cy="274320"/>
+          </a:xfrm>
+          <a:prstGeom prst="rect">
+            <a:avLst/>
+          </a:prstGeom>
+          <a:noFill/>
+          <a:ln/>
+        </p:spPr>
+        <p:txBody>
+          <a:bodyPr wrap="square" lIns="0" tIns="0" rIns="0" bIns="0" rtlCol="0" anchor="ctr"/>
+          <a:lstStyle/>
+          <a:p>
+            <a:pPr algn="l" indent="0" marL="0">
+              <a:buNone/>
+            </a:pPr>
+            <a:r>
+              <a:rPr lang="en-US" sz="1400" b="1" dirty="0">
+                <a:solidFill>
+                  <a:srgbClr val="1B2B3A"/>
+                </a:solidFill>
+                <a:latin typeface="Calibri" pitchFamily="34" charset="0"/>
+                <a:ea typeface="Calibri" pitchFamily="34" charset="-122"/>
+                <a:cs typeface="Calibri" pitchFamily="34" charset="-120"/>
+              </a:rPr>
+              <a:t>1</a:t>
+            </a:r>
+            <a:endParaRPr lang="en-US" sz="1400" dirty="0"/>
+          </a:p>
+        </p:txBody>
+      </p:sp>
+      <p:sp>
+        <p:nvSpPr>
+          <p:cNvPr id="34" name="Text 29"/>
+          <p:cNvSpPr txBox="1"/>
+          <p:nvPr/>
+        </p:nvSpPr>
+        <p:spPr>
+          <a:xfrm>
+            <a:off x="6400800" y="5650992"/>
+            <a:ext cx="1188720" cy="274320"/>
+          </a:xfrm>
+          <a:prstGeom prst="rect">
+            <a:avLst/>
+          </a:prstGeom>
+          <a:noFill/>
+          <a:ln/>
+        </p:spPr>
+        <p:txBody>
+          <a:bodyPr wrap="square" lIns="0" tIns="0" rIns="0" bIns="0" rtlCol="0" anchor="ctr"/>
+          <a:lstStyle/>
+          <a:p>
+            <a:pPr algn="l" indent="0" marL="0">
+              <a:buNone/>
+            </a:pPr>
+            <a:r>
+              <a:rPr lang="en-US" sz="1400" dirty="0">
+                <a:solidFill>
+                  <a:srgbClr val="5A6B7D"/>
+                </a:solidFill>
+                <a:latin typeface="Calibri" pitchFamily="34" charset="0"/>
+                <a:ea typeface="Calibri" pitchFamily="34" charset="-122"/>
+                <a:cs typeface="Calibri" pitchFamily="34" charset="-120"/>
+              </a:rPr>
+              <a:t>play ×6</a:t>
+            </a:r>
+            <a:endParaRPr lang="en-US" sz="1400" dirty="0"/>
+          </a:p>
+        </p:txBody>
+      </p:sp>
+      <p:sp>
+        <p:nvSpPr>
+          <p:cNvPr id="35" name="Shape 30"/>
           <p:cNvSpPr/>
           <p:nvPr/>
         </p:nvSpPr>
         <p:spPr>
           <a:xfrm>
-            <a:off x="9875520" y="5440680"/>
-            <a:ext cx="1737360" cy="365760"/>
+            <a:off x="7635240" y="5678424"/>
+            <a:ext cx="877824" cy="219456"/>
           </a:xfrm>
           <a:prstGeom prst="rect">
             <a:avLst/>
           </a:prstGeom>
           <a:solidFill>
-            <a:srgbClr val="E2574C"/>
+            <a:srgbClr val="1FB5A8"/>
           </a:solidFill>
           <a:ln w="6350">
             <a:solidFill>
-              <a:srgbClr val="E2574C"/>
+              <a:srgbClr val="1FB5A8"/>
             </a:solidFill>
             <a:prstDash val="solid"/>
           </a:ln>
@@ -4573,14 +4665,14 @@
       </p:sp>
       <p:sp>
         <p:nvSpPr>
-          <p:cNvPr id="34" name="Text 29"/>
-          <p:cNvSpPr txBox="1"/>
-          <p:nvPr/>
-        </p:nvSpPr>
-        <p:spPr>
-          <a:xfrm>
-            <a:off x="6400800" y="5897880"/>
-            <a:ext cx="5212080" cy="365760"/>
+          <p:cNvPr id="36" name="Text 31"/>
+          <p:cNvSpPr txBox="1"/>
+          <p:nvPr/>
+        </p:nvSpPr>
+        <p:spPr>
+          <a:xfrm>
+            <a:off x="8622792" y="5650992"/>
+            <a:ext cx="2926080" cy="274320"/>
           </a:xfrm>
           <a:prstGeom prst="rect">
             <a:avLst/>
@@ -4589,24 +4681,127 @@
           <a:ln/>
         </p:spPr>
         <p:txBody>
-          <a:bodyPr wrap="square" lIns="0" tIns="0" rIns="0" bIns="0" rtlCol="0" anchor="t"/>
+          <a:bodyPr wrap="square" lIns="0" tIns="0" rIns="0" bIns="0" rtlCol="0" anchor="ctr"/>
           <a:lstStyle/>
           <a:p>
             <a:pPr algn="l" indent="0" marL="0">
               <a:buNone/>
             </a:pPr>
             <a:r>
-              <a:rPr lang="en-US" sz="1500" b="1" dirty="0">
-                <a:solidFill>
-                  <a:srgbClr val="14325C"/>
-                </a:solidFill>
-                <a:latin typeface="Calibri" pitchFamily="34" charset="0"/>
-                <a:ea typeface="Calibri" pitchFamily="34" charset="-122"/>
-                <a:cs typeface="Calibri" pitchFamily="34" charset="-120"/>
-              </a:rPr>
-              <a:t>Open DR_Lab.html → tab 3</a:t>
-            </a:r>
-            <a:endParaRPr lang="en-US" sz="1500" dirty="0"/>
+              <a:rPr lang="en-US" sz="1400" b="1" dirty="0">
+                <a:solidFill>
+                  <a:srgbClr val="1B2B3A"/>
+                </a:solidFill>
+                <a:latin typeface="Calibri" pitchFamily="34" charset="0"/>
+                <a:ea typeface="Calibri" pitchFamily="34" charset="-122"/>
+                <a:cs typeface="Calibri" pitchFamily="34" charset="-120"/>
+              </a:rPr>
+              <a:t>6 × initial</a:t>
+            </a:r>
+            <a:endParaRPr lang="en-US" sz="1400" dirty="0"/>
+          </a:p>
+        </p:txBody>
+      </p:sp>
+      <p:sp>
+        <p:nvSpPr>
+          <p:cNvPr id="37" name="Text 32"/>
+          <p:cNvSpPr txBox="1"/>
+          <p:nvPr/>
+        </p:nvSpPr>
+        <p:spPr>
+          <a:xfrm>
+            <a:off x="6400800" y="5980176"/>
+            <a:ext cx="1188720" cy="274320"/>
+          </a:xfrm>
+          <a:prstGeom prst="rect">
+            <a:avLst/>
+          </a:prstGeom>
+          <a:noFill/>
+          <a:ln/>
+        </p:spPr>
+        <p:txBody>
+          <a:bodyPr wrap="square" lIns="0" tIns="0" rIns="0" bIns="0" rtlCol="0" anchor="ctr"/>
+          <a:lstStyle/>
+          <a:p>
+            <a:pPr algn="l" indent="0" marL="0">
+              <a:buNone/>
+            </a:pPr>
+            <a:r>
+              <a:rPr lang="en-US" sz="1400" dirty="0">
+                <a:solidFill>
+                  <a:srgbClr val="5A6B7D"/>
+                </a:solidFill>
+                <a:latin typeface="Calibri" pitchFamily="34" charset="0"/>
+                <a:ea typeface="Calibri" pitchFamily="34" charset="-122"/>
+                <a:cs typeface="Calibri" pitchFamily="34" charset="-120"/>
+              </a:rPr>
+              <a:t>then ×10</a:t>
+            </a:r>
+            <a:endParaRPr lang="en-US" sz="1400" dirty="0"/>
+          </a:p>
+        </p:txBody>
+      </p:sp>
+      <p:sp>
+        <p:nvSpPr>
+          <p:cNvPr id="38" name="Shape 33"/>
+          <p:cNvSpPr/>
+          <p:nvPr/>
+        </p:nvSpPr>
+        <p:spPr>
+          <a:xfrm>
+            <a:off x="7635240" y="6007608"/>
+            <a:ext cx="1463040" cy="219456"/>
+          </a:xfrm>
+          <a:prstGeom prst="rect">
+            <a:avLst/>
+          </a:prstGeom>
+          <a:solidFill>
+            <a:srgbClr val="1FB5A8"/>
+          </a:solidFill>
+          <a:ln w="6350">
+            <a:solidFill>
+              <a:srgbClr val="1FB5A8"/>
+            </a:solidFill>
+            <a:prstDash val="solid"/>
+          </a:ln>
+        </p:spPr>
+      </p:sp>
+      <p:sp>
+        <p:nvSpPr>
+          <p:cNvPr id="39" name="Text 34"/>
+          <p:cNvSpPr txBox="1"/>
+          <p:nvPr/>
+        </p:nvSpPr>
+        <p:spPr>
+          <a:xfrm>
+            <a:off x="9208008" y="5980176"/>
+            <a:ext cx="2926080" cy="274320"/>
+          </a:xfrm>
+          <a:prstGeom prst="rect">
+            <a:avLst/>
+          </a:prstGeom>
+          <a:noFill/>
+          <a:ln/>
+        </p:spPr>
+        <p:txBody>
+          <a:bodyPr wrap="square" lIns="0" tIns="0" rIns="0" bIns="0" rtlCol="0" anchor="ctr"/>
+          <a:lstStyle/>
+          <a:p>
+            <a:pPr algn="l" indent="0" marL="0">
+              <a:buNone/>
+            </a:pPr>
+            <a:r>
+              <a:rPr lang="en-US" sz="1400" b="1" dirty="0">
+                <a:solidFill>
+                  <a:srgbClr val="1B2B3A"/>
+                </a:solidFill>
+                <a:latin typeface="Calibri" pitchFamily="34" charset="0"/>
+                <a:ea typeface="Calibri" pitchFamily="34" charset="-122"/>
+                <a:cs typeface="Calibri" pitchFamily="34" charset="-120"/>
+              </a:rPr>
+              <a:t>10 × initial (not 60)</a:t>
+            </a:r>
+            <a:endParaRPr lang="en-US" sz="1400" dirty="0"/>
           </a:p>
         </p:txBody>
       </p:sp>

</xml_diff>

<commit_message>
Blackjack: cards chain on the last scan again; add START reference column
Reverts the "initial x card" rule: each card multiplies the team's last
scan (less predictable, fractional cards useful again). Once any team has
played, the original grainy image appears as a 4th column between Team Left
and Ideal. History keeps two rows with multipliers. Rules screen, slide 11,
script, guide and checklist updated.

Co-Authored-By: Claude Sonnet 5.5 <noreply@anthropic.com>
</commit_message>
<xml_diff>
--- a/DR_Overview.pptx
+++ b/DR_Overview.pptx
@@ -782,7 +782,7 @@
           <a:p>
             <a:r>
               <a:rPr lang="en-US" dirty="0"/>
-              <a:t>D hosts; A clicks cards, B referees, C collects Team Left votes. Split the room into Team Left and Team Right, each with a captain. Both teams start from the same grainy image; the ideal image is always on screen. Each round, a team plays a multiplier card; the new scan is the INITIAL exposure times the card (not the last scan times the card), so every card is a fresh scan and more dose. The new image appears for both teams, so they compare. Cards: x2 to x6 are still grainy, x8 and x10 land at about the ideal, x15 is wasteful overexposure that looks identical, x40 looks fine but blows the dose limit. The first team's card is blocked for the second team that round. First pick alternates (the Random button decides round 1). Clocks: 30 seconds per turn (timeout means that team stands) and 3 minutes for the whole game (when it ends both teams stand). Up to 4 rounds or STAND; a team that stands is out, but the other team keeps playing all its remaining rounds, so standing early gives no advantage. The last image is the submission. Score = Quality x 2 minus Dose; quality is hidden until the reveal, dose is the bar. About 25 s per round. Then press Reveal and hand to slide 12.</a:t>
+              <a:t>D hosts; A clicks cards, B referees, C collects Team Left votes. Split the room into Team Left and Team Right, each with a captain. Both teams start from the same grainy image; the ideal image is always on screen. Each round, a team plays a multiplier card on its own last scan, so cards chain (x6 then x3 = x18 of the start). The new image appears for both teams, so they compare; once anyone has played, the START image appears as a reference column. The first team's card is blocked for the second team that round. First pick alternates (the Random button decides round 1). Clocks: 30 seconds per turn (timeout means that team stands) and 3 minutes for the whole game (when it ends both teams stand). Up to 4 rounds or STAND; a team that stands is out, but the other team keeps playing all its remaining rounds, so standing early gives no advantage. The last image is the submission. Score = Quality x 2 minus Dose; quality is hidden until the reveal, dose is the bar. About 25 s per round. Then press Reveal and hand to slide 12.</a:t>
             </a:r>
             <a:endParaRPr lang="en-US" dirty="0"/>
           </a:p>
@@ -3710,7 +3710,7 @@
                 <a:ea typeface="Calibri" pitchFamily="34" charset="-122"/>
                 <a:cs typeface="Calibri" pitchFamily="34" charset="-120"/>
               </a:rPr>
-              <a:t>Each round: play a × card. New scan = initial × card, not last scan × card.</a:t>
+              <a:t>Each round: play a × card. It multiplies your last scan, so cards chain.</a:t>
             </a:r>
             <a:endParaRPr lang="en-US" sz="1800" dirty="0"/>
           </a:p>
@@ -4122,7 +4122,7 @@
                 <a:ea typeface="Calibri" pitchFamily="34" charset="-122"/>
                 <a:cs typeface="Calibri" pitchFamily="34" charset="-120"/>
               </a:rPr>
-              <a:t>×2</a:t>
+              <a:t>×⅙</a:t>
             </a:r>
             <a:endParaRPr lang="en-US" sz="1800" dirty="0"/>
           </a:p>
@@ -4169,7 +4169,7 @@
                 <a:ea typeface="Calibri" pitchFamily="34" charset="-122"/>
                 <a:cs typeface="Calibri" pitchFamily="34" charset="-120"/>
               </a:rPr>
-              <a:t>×3</a:t>
+              <a:t>×¼</a:t>
             </a:r>
             <a:endParaRPr lang="en-US" sz="1800" dirty="0"/>
           </a:p>
@@ -4216,7 +4216,7 @@
                 <a:ea typeface="Calibri" pitchFamily="34" charset="-122"/>
                 <a:cs typeface="Calibri" pitchFamily="34" charset="-120"/>
               </a:rPr>
-              <a:t>×4</a:t>
+              <a:t>×⅓</a:t>
             </a:r>
             <a:endParaRPr lang="en-US" sz="1800" dirty="0"/>
           </a:p>
@@ -4263,7 +4263,7 @@
                 <a:ea typeface="Calibri" pitchFamily="34" charset="-122"/>
                 <a:cs typeface="Calibri" pitchFamily="34" charset="-120"/>
               </a:rPr>
-              <a:t>×6</a:t>
+              <a:t>×½</a:t>
             </a:r>
             <a:endParaRPr lang="en-US" sz="1800" dirty="0"/>
           </a:p>
@@ -4310,7 +4310,7 @@
                 <a:ea typeface="Calibri" pitchFamily="34" charset="-122"/>
                 <a:cs typeface="Calibri" pitchFamily="34" charset="-120"/>
               </a:rPr>
-              <a:t>×8</a:t>
+              <a:t>×2</a:t>
             </a:r>
             <a:endParaRPr lang="en-US" sz="1800" dirty="0"/>
           </a:p>
@@ -4357,7 +4357,7 @@
                 <a:ea typeface="Calibri" pitchFamily="34" charset="-122"/>
                 <a:cs typeface="Calibri" pitchFamily="34" charset="-120"/>
               </a:rPr>
-              <a:t>×10</a:t>
+              <a:t>×3</a:t>
             </a:r>
             <a:endParaRPr lang="en-US" sz="1800" dirty="0"/>
           </a:p>
@@ -4404,7 +4404,7 @@
                 <a:ea typeface="Calibri" pitchFamily="34" charset="-122"/>
                 <a:cs typeface="Calibri" pitchFamily="34" charset="-120"/>
               </a:rPr>
-              <a:t>×15</a:t>
+              <a:t>×4</a:t>
             </a:r>
             <a:endParaRPr lang="en-US" sz="1800" dirty="0"/>
           </a:p>
@@ -4451,7 +4451,7 @@
                 <a:ea typeface="Calibri" pitchFamily="34" charset="-122"/>
                 <a:cs typeface="Calibri" pitchFamily="34" charset="-120"/>
               </a:rPr>
-              <a:t>×40</a:t>
+              <a:t>×6</a:t>
             </a:r>
             <a:endParaRPr lang="en-US" sz="1800" dirty="0"/>
           </a:p>
@@ -4490,7 +4490,7 @@
                 <a:ea typeface="Calibri" pitchFamily="34" charset="-122"/>
                 <a:cs typeface="Calibri" pitchFamily="34" charset="-120"/>
               </a:rPr>
-              <a:t>Cards multiply the INITIAL scan, not your last scan</a:t>
+              <a:t>Cards chain on your last scan</a:t>
             </a:r>
             <a:endParaRPr lang="en-US" sz="1500" dirty="0"/>
           </a:p>
@@ -4529,7 +4529,7 @@
                 <a:ea typeface="Calibri" pitchFamily="34" charset="-122"/>
                 <a:cs typeface="Calibri" pitchFamily="34" charset="-120"/>
               </a:rPr>
-              <a:t>initial</a:t>
+              <a:t>start</a:t>
             </a:r>
             <a:endParaRPr lang="en-US" sz="1400" dirty="0"/>
           </a:p>
@@ -4544,7 +4544,7 @@
         <p:spPr>
           <a:xfrm>
             <a:off x="7635240" y="5349240"/>
-            <a:ext cx="146304" cy="219456"/>
+            <a:ext cx="91440" cy="219456"/>
           </a:xfrm>
           <a:prstGeom prst="rect">
             <a:avLst/>
@@ -4568,7 +4568,7 @@
         </p:nvSpPr>
         <p:spPr>
           <a:xfrm>
-            <a:off x="7891272" y="5321808"/>
+            <a:off x="7836408" y="5321808"/>
             <a:ext cx="2926080" cy="274320"/>
           </a:xfrm>
           <a:prstGeom prst="rect">
@@ -4647,7 +4647,7 @@
         <p:spPr>
           <a:xfrm>
             <a:off x="7635240" y="5678424"/>
-            <a:ext cx="877824" cy="219456"/>
+            <a:ext cx="548640" cy="219456"/>
           </a:xfrm>
           <a:prstGeom prst="rect">
             <a:avLst/>
@@ -4671,7 +4671,7 @@
         </p:nvSpPr>
         <p:spPr>
           <a:xfrm>
-            <a:off x="8622792" y="5650992"/>
+            <a:off x="8293608" y="5650992"/>
             <a:ext cx="2926080" cy="274320"/>
           </a:xfrm>
           <a:prstGeom prst="rect">
@@ -4696,7 +4696,7 @@
                 <a:ea typeface="Calibri" pitchFamily="34" charset="-122"/>
                 <a:cs typeface="Calibri" pitchFamily="34" charset="-120"/>
               </a:rPr>
-              <a:t>6 × initial</a:t>
+              <a:t>= 6 × start</a:t>
             </a:r>
             <a:endParaRPr lang="en-US" sz="1400" dirty="0"/>
           </a:p>
@@ -4735,7 +4735,7 @@
                 <a:ea typeface="Calibri" pitchFamily="34" charset="-122"/>
                 <a:cs typeface="Calibri" pitchFamily="34" charset="-120"/>
               </a:rPr>
-              <a:t>then ×10</a:t>
+              <a:t>then ×3</a:t>
             </a:r>
             <a:endParaRPr lang="en-US" sz="1400" dirty="0"/>
           </a:p>
@@ -4750,7 +4750,7 @@
         <p:spPr>
           <a:xfrm>
             <a:off x="7635240" y="6007608"/>
-            <a:ext cx="1463040" cy="219456"/>
+            <a:ext cx="1645920" cy="219456"/>
           </a:xfrm>
           <a:prstGeom prst="rect">
             <a:avLst/>
@@ -4774,7 +4774,7 @@
         </p:nvSpPr>
         <p:spPr>
           <a:xfrm>
-            <a:off x="9208008" y="5980176"/>
+            <a:off x="9390888" y="5980176"/>
             <a:ext cx="2926080" cy="274320"/>
           </a:xfrm>
           <a:prstGeom prst="rect">
@@ -4799,7 +4799,7 @@
                 <a:ea typeface="Calibri" pitchFamily="34" charset="-122"/>
                 <a:cs typeface="Calibri" pitchFamily="34" charset="-120"/>
               </a:rPr>
-              <a:t>10 × initial (not 60)</a:t>
+              <a:t>= 18 × start</a:t>
             </a:r>
             <a:endParaRPr lang="en-US" sz="1400" dirty="0"/>
           </a:p>

</xml_diff>

<commit_message>
Blackjack: add x1.5 card (nine cards, keys 1-9)
Best route becomes x1.5 then x6 = 180.2 (x3 then x3 = 178.4); order
matters (x6 then x1.5 = 174.8). Engine tests, rules screen, slide 11,
script, guide and checklist updated.

Co-Authored-By: Claude Sonnet 5.5 <noreply@anthropic.com>
</commit_message>
<xml_diff>
--- a/DR_Overview.pptx
+++ b/DR_Overview.pptx
@@ -782,7 +782,7 @@
           <a:p>
             <a:r>
               <a:rPr lang="en-US" dirty="0"/>
-              <a:t>D hosts; A clicks cards, B referees, C collects Team Left votes. Split the room into Team Left and Team Right, each with a captain. Both teams start from the same grainy image; the ideal image is always on screen. Each round, a team plays a multiplier card on its own last scan, so cards chain (x6 then x3 = x18 of the start). The new image appears for both teams, so they compare; once anyone has played, the START image appears as a reference column. The first team's card is blocked for the second team that round. First pick alternates (the Random button decides round 1). Clocks: 30 seconds per turn (timeout means that team stands) and 3 minutes for the whole game (when it ends both teams stand). Up to 4 rounds or STAND; a team that stands is out, but the other team keeps playing all its remaining rounds, so standing early gives no advantage. The last image is the submission. Score = Quality x 2 minus Dose; quality is hidden until the reveal, dose is the bar. About 25 s per round. Then press Reveal and hand to slide 12.</a:t>
+              <a:t>D hosts; A clicks cards, B referees, C collects Team Left votes. Split the room into Team Left and Team Right, each with a captain. Both teams start from the same grainy image; the ideal image is always on screen. Each round, a team plays a multiplier card on its own last scan, so cards chain (x6 then x1.5 = x9 of the start). The new image appears for both teams, so they compare; once anyone has played, the START image appears as a reference column. The first team's card is blocked for the second team that round. First pick alternates (the Random button decides round 1). Clocks: 30 seconds per turn (timeout means that team stands) and 3 minutes for the whole game (when it ends both teams stand). Up to 4 rounds or STAND; a team that stands is out, but the other team keeps playing all its remaining rounds, so standing early gives no advantage. The last image is the submission. Score = Quality x 2 minus Dose; quality is hidden until the reveal, dose is the bar. About 25 s per round. Then press Reveal and hand to slide 12.</a:t>
             </a:r>
             <a:endParaRPr lang="en-US" dirty="0"/>
           </a:p>
@@ -4090,7 +4090,7 @@
         <p:spPr>
           <a:xfrm>
             <a:off x="6400800" y="4297680"/>
-            <a:ext cx="594360" cy="548640"/>
+            <a:ext cx="548640" cy="548640"/>
           </a:xfrm>
           <a:prstGeom prst="roundRect">
             <a:avLst>
@@ -4114,7 +4114,7 @@
               <a:buNone/>
             </a:pPr>
             <a:r>
-              <a:rPr lang="en-US" sz="1800" b="1" dirty="0">
+              <a:rPr lang="en-US" sz="1500" b="1" dirty="0">
                 <a:solidFill>
                   <a:srgbClr val="1B2B3A"/>
                 </a:solidFill>
@@ -4124,7 +4124,7 @@
               </a:rPr>
               <a:t>×⅙</a:t>
             </a:r>
-            <a:endParaRPr lang="en-US" sz="1800" dirty="0"/>
+            <a:endParaRPr lang="en-US" sz="1500" dirty="0"/>
           </a:p>
         </p:txBody>
       </p:sp>
@@ -4136,8 +4136,8 @@
         </p:nvSpPr>
         <p:spPr>
           <a:xfrm>
-            <a:off x="7068312" y="4297680"/>
-            <a:ext cx="594360" cy="548640"/>
+            <a:off x="7004304" y="4297680"/>
+            <a:ext cx="548640" cy="548640"/>
           </a:xfrm>
           <a:prstGeom prst="roundRect">
             <a:avLst>
@@ -4161,7 +4161,7 @@
               <a:buNone/>
             </a:pPr>
             <a:r>
-              <a:rPr lang="en-US" sz="1800" b="1" dirty="0">
+              <a:rPr lang="en-US" sz="1500" b="1" dirty="0">
                 <a:solidFill>
                   <a:srgbClr val="1B2B3A"/>
                 </a:solidFill>
@@ -4171,7 +4171,7 @@
               </a:rPr>
               <a:t>×¼</a:t>
             </a:r>
-            <a:endParaRPr lang="en-US" sz="1800" dirty="0"/>
+            <a:endParaRPr lang="en-US" sz="1500" dirty="0"/>
           </a:p>
         </p:txBody>
       </p:sp>
@@ -4183,8 +4183,8 @@
         </p:nvSpPr>
         <p:spPr>
           <a:xfrm>
-            <a:off x="7735824" y="4297680"/>
-            <a:ext cx="594360" cy="548640"/>
+            <a:off x="7607808" y="4297680"/>
+            <a:ext cx="548640" cy="548640"/>
           </a:xfrm>
           <a:prstGeom prst="roundRect">
             <a:avLst>
@@ -4208,7 +4208,7 @@
               <a:buNone/>
             </a:pPr>
             <a:r>
-              <a:rPr lang="en-US" sz="1800" b="1" dirty="0">
+              <a:rPr lang="en-US" sz="1500" b="1" dirty="0">
                 <a:solidFill>
                   <a:srgbClr val="1B2B3A"/>
                 </a:solidFill>
@@ -4218,7 +4218,7 @@
               </a:rPr>
               <a:t>×⅓</a:t>
             </a:r>
-            <a:endParaRPr lang="en-US" sz="1800" dirty="0"/>
+            <a:endParaRPr lang="en-US" sz="1500" dirty="0"/>
           </a:p>
         </p:txBody>
       </p:sp>
@@ -4230,8 +4230,8 @@
         </p:nvSpPr>
         <p:spPr>
           <a:xfrm>
-            <a:off x="8403336" y="4297680"/>
-            <a:ext cx="594360" cy="548640"/>
+            <a:off x="8211312" y="4297680"/>
+            <a:ext cx="548640" cy="548640"/>
           </a:xfrm>
           <a:prstGeom prst="roundRect">
             <a:avLst>
@@ -4255,7 +4255,7 @@
               <a:buNone/>
             </a:pPr>
             <a:r>
-              <a:rPr lang="en-US" sz="1800" b="1" dirty="0">
+              <a:rPr lang="en-US" sz="1500" b="1" dirty="0">
                 <a:solidFill>
                   <a:srgbClr val="1B2B3A"/>
                 </a:solidFill>
@@ -4265,7 +4265,7 @@
               </a:rPr>
               <a:t>×½</a:t>
             </a:r>
-            <a:endParaRPr lang="en-US" sz="1800" dirty="0"/>
+            <a:endParaRPr lang="en-US" sz="1500" dirty="0"/>
           </a:p>
         </p:txBody>
       </p:sp>
@@ -4277,8 +4277,8 @@
         </p:nvSpPr>
         <p:spPr>
           <a:xfrm>
-            <a:off x="9070848" y="4297680"/>
-            <a:ext cx="594360" cy="548640"/>
+            <a:off x="8814816" y="4297680"/>
+            <a:ext cx="548640" cy="548640"/>
           </a:xfrm>
           <a:prstGeom prst="roundRect">
             <a:avLst>
@@ -4302,7 +4302,7 @@
               <a:buNone/>
             </a:pPr>
             <a:r>
-              <a:rPr lang="en-US" sz="1800" b="1" dirty="0">
+              <a:rPr lang="en-US" sz="1500" b="1" dirty="0">
                 <a:solidFill>
                   <a:srgbClr val="1B2B3A"/>
                 </a:solidFill>
@@ -4310,9 +4310,9 @@
                 <a:ea typeface="Calibri" pitchFamily="34" charset="-122"/>
                 <a:cs typeface="Calibri" pitchFamily="34" charset="-120"/>
               </a:rPr>
-              <a:t>×2</a:t>
-            </a:r>
-            <a:endParaRPr lang="en-US" sz="1800" dirty="0"/>
+              <a:t>×1.5</a:t>
+            </a:r>
+            <a:endParaRPr lang="en-US" sz="1500" dirty="0"/>
           </a:p>
         </p:txBody>
       </p:sp>
@@ -4324,8 +4324,8 @@
         </p:nvSpPr>
         <p:spPr>
           <a:xfrm>
-            <a:off x="9738360" y="4297680"/>
-            <a:ext cx="594360" cy="548640"/>
+            <a:off x="9418320" y="4297680"/>
+            <a:ext cx="548640" cy="548640"/>
           </a:xfrm>
           <a:prstGeom prst="roundRect">
             <a:avLst>
@@ -4349,7 +4349,7 @@
               <a:buNone/>
             </a:pPr>
             <a:r>
-              <a:rPr lang="en-US" sz="1800" b="1" dirty="0">
+              <a:rPr lang="en-US" sz="1500" b="1" dirty="0">
                 <a:solidFill>
                   <a:srgbClr val="1B2B3A"/>
                 </a:solidFill>
@@ -4357,9 +4357,9 @@
                 <a:ea typeface="Calibri" pitchFamily="34" charset="-122"/>
                 <a:cs typeface="Calibri" pitchFamily="34" charset="-120"/>
               </a:rPr>
-              <a:t>×3</a:t>
-            </a:r>
-            <a:endParaRPr lang="en-US" sz="1800" dirty="0"/>
+              <a:t>×2</a:t>
+            </a:r>
+            <a:endParaRPr lang="en-US" sz="1500" dirty="0"/>
           </a:p>
         </p:txBody>
       </p:sp>
@@ -4371,8 +4371,8 @@
         </p:nvSpPr>
         <p:spPr>
           <a:xfrm>
-            <a:off x="10405872" y="4297680"/>
-            <a:ext cx="594360" cy="548640"/>
+            <a:off x="10021824" y="4297680"/>
+            <a:ext cx="548640" cy="548640"/>
           </a:xfrm>
           <a:prstGeom prst="roundRect">
             <a:avLst>
@@ -4396,7 +4396,7 @@
               <a:buNone/>
             </a:pPr>
             <a:r>
-              <a:rPr lang="en-US" sz="1800" b="1" dirty="0">
+              <a:rPr lang="en-US" sz="1500" b="1" dirty="0">
                 <a:solidFill>
                   <a:srgbClr val="1B2B3A"/>
                 </a:solidFill>
@@ -4404,9 +4404,9 @@
                 <a:ea typeface="Calibri" pitchFamily="34" charset="-122"/>
                 <a:cs typeface="Calibri" pitchFamily="34" charset="-120"/>
               </a:rPr>
-              <a:t>×4</a:t>
-            </a:r>
-            <a:endParaRPr lang="en-US" sz="1800" dirty="0"/>
+              <a:t>×3</a:t>
+            </a:r>
+            <a:endParaRPr lang="en-US" sz="1500" dirty="0"/>
           </a:p>
         </p:txBody>
       </p:sp>
@@ -4418,8 +4418,8 @@
         </p:nvSpPr>
         <p:spPr>
           <a:xfrm>
-            <a:off x="11073384" y="4297680"/>
-            <a:ext cx="594360" cy="548640"/>
+            <a:off x="10625328" y="4297680"/>
+            <a:ext cx="548640" cy="548640"/>
           </a:xfrm>
           <a:prstGeom prst="roundRect">
             <a:avLst>
@@ -4443,7 +4443,7 @@
               <a:buNone/>
             </a:pPr>
             <a:r>
-              <a:rPr lang="en-US" sz="1800" b="1" dirty="0">
+              <a:rPr lang="en-US" sz="1500" b="1" dirty="0">
                 <a:solidFill>
                   <a:srgbClr val="1B2B3A"/>
                 </a:solidFill>
@@ -4451,15 +4451,62 @@
                 <a:ea typeface="Calibri" pitchFamily="34" charset="-122"/>
                 <a:cs typeface="Calibri" pitchFamily="34" charset="-120"/>
               </a:rPr>
+              <a:t>×4</a:t>
+            </a:r>
+            <a:endParaRPr lang="en-US" sz="1500" dirty="0"/>
+          </a:p>
+        </p:txBody>
+      </p:sp>
+      <p:sp>
+        <p:nvSpPr>
+          <p:cNvPr id="30" name="Text 25"/>
+          <p:cNvSpPr txBox="1"/>
+          <p:nvPr/>
+        </p:nvSpPr>
+        <p:spPr>
+          <a:xfrm>
+            <a:off x="11228832" y="4297680"/>
+            <a:ext cx="548640" cy="548640"/>
+          </a:xfrm>
+          <a:prstGeom prst="roundRect">
+            <a:avLst>
+              <a:gd name="adj" fmla="val 13333"/>
+            </a:avLst>
+          </a:prstGeom>
+          <a:solidFill>
+            <a:srgbClr val="FFFFFF"/>
+          </a:solidFill>
+          <a:ln w="19050">
+            <a:solidFill>
+              <a:srgbClr val="14325C"/>
+            </a:solidFill>
+          </a:ln>
+        </p:spPr>
+        <p:txBody>
+          <a:bodyPr wrap="square" lIns="0" tIns="0" rIns="0" bIns="0" rtlCol="0" anchor="ctr"/>
+          <a:lstStyle/>
+          <a:p>
+            <a:pPr algn="ctr" indent="0" marL="0">
+              <a:buNone/>
+            </a:pPr>
+            <a:r>
+              <a:rPr lang="en-US" sz="1500" b="1" dirty="0">
+                <a:solidFill>
+                  <a:srgbClr val="1B2B3A"/>
+                </a:solidFill>
+                <a:latin typeface="Calibri" pitchFamily="34" charset="0"/>
+                <a:ea typeface="Calibri" pitchFamily="34" charset="-122"/>
+                <a:cs typeface="Calibri" pitchFamily="34" charset="-120"/>
+              </a:rPr>
               <a:t>×6</a:t>
             </a:r>
-            <a:endParaRPr lang="en-US" sz="1800" dirty="0"/>
-          </a:p>
-        </p:txBody>
-      </p:sp>
-      <p:sp>
-        <p:nvSpPr>
-          <p:cNvPr id="30" name="Text 25"/>
+            <a:endParaRPr lang="en-US" sz="1500" dirty="0"/>
+          </a:p>
+        </p:txBody>
+      </p:sp>
+      <p:sp>
+        <p:nvSpPr>
+          <p:cNvPr id="31" name="Text 26"/>
           <p:cNvSpPr txBox="1"/>
           <p:nvPr/>
         </p:nvSpPr>
@@ -4498,7 +4545,7 @@
       </p:sp>
       <p:sp>
         <p:nvSpPr>
-          <p:cNvPr id="31" name="Text 26"/>
+          <p:cNvPr id="32" name="Text 27"/>
           <p:cNvSpPr txBox="1"/>
           <p:nvPr/>
         </p:nvSpPr>
@@ -4537,7 +4584,7 @@
       </p:sp>
       <p:sp>
         <p:nvSpPr>
-          <p:cNvPr id="32" name="Shape 27"/>
+          <p:cNvPr id="33" name="Shape 28"/>
           <p:cNvSpPr/>
           <p:nvPr/>
         </p:nvSpPr>
@@ -4562,7 +4609,7 @@
       </p:sp>
       <p:sp>
         <p:nvSpPr>
-          <p:cNvPr id="33" name="Text 28"/>
+          <p:cNvPr id="34" name="Text 29"/>
           <p:cNvSpPr txBox="1"/>
           <p:nvPr/>
         </p:nvSpPr>
@@ -4601,7 +4648,7 @@
       </p:sp>
       <p:sp>
         <p:nvSpPr>
-          <p:cNvPr id="34" name="Text 29"/>
+          <p:cNvPr id="35" name="Text 30"/>
           <p:cNvSpPr txBox="1"/>
           <p:nvPr/>
         </p:nvSpPr>
@@ -4640,7 +4687,7 @@
       </p:sp>
       <p:sp>
         <p:nvSpPr>
-          <p:cNvPr id="35" name="Shape 30"/>
+          <p:cNvPr id="36" name="Shape 31"/>
           <p:cNvSpPr/>
           <p:nvPr/>
         </p:nvSpPr>
@@ -4665,7 +4712,7 @@
       </p:sp>
       <p:sp>
         <p:nvSpPr>
-          <p:cNvPr id="36" name="Text 31"/>
+          <p:cNvPr id="37" name="Text 32"/>
           <p:cNvSpPr txBox="1"/>
           <p:nvPr/>
         </p:nvSpPr>
@@ -4704,7 +4751,7 @@
       </p:sp>
       <p:sp>
         <p:nvSpPr>
-          <p:cNvPr id="37" name="Text 32"/>
+          <p:cNvPr id="38" name="Text 33"/>
           <p:cNvSpPr txBox="1"/>
           <p:nvPr/>
         </p:nvSpPr>
@@ -4735,7 +4782,7 @@
                 <a:ea typeface="Calibri" pitchFamily="34" charset="-122"/>
                 <a:cs typeface="Calibri" pitchFamily="34" charset="-120"/>
               </a:rPr>
-              <a:t>then ×3</a:t>
+              <a:t>then ×1.5</a:t>
             </a:r>
             <a:endParaRPr lang="en-US" sz="1400" dirty="0"/>
           </a:p>
@@ -4743,14 +4790,14 @@
       </p:sp>
       <p:sp>
         <p:nvSpPr>
-          <p:cNvPr id="38" name="Shape 33"/>
+          <p:cNvPr id="39" name="Shape 34"/>
           <p:cNvSpPr/>
           <p:nvPr/>
         </p:nvSpPr>
         <p:spPr>
           <a:xfrm>
             <a:off x="7635240" y="6007608"/>
-            <a:ext cx="1645920" cy="219456"/>
+            <a:ext cx="822960" cy="219456"/>
           </a:xfrm>
           <a:prstGeom prst="rect">
             <a:avLst/>
@@ -4768,13 +4815,13 @@
       </p:sp>
       <p:sp>
         <p:nvSpPr>
-          <p:cNvPr id="39" name="Text 34"/>
-          <p:cNvSpPr txBox="1"/>
-          <p:nvPr/>
-        </p:nvSpPr>
-        <p:spPr>
-          <a:xfrm>
-            <a:off x="9390888" y="5980176"/>
+          <p:cNvPr id="40" name="Text 35"/>
+          <p:cNvSpPr txBox="1"/>
+          <p:nvPr/>
+        </p:nvSpPr>
+        <p:spPr>
+          <a:xfrm>
+            <a:off x="8567928" y="5980176"/>
             <a:ext cx="2926080" cy="274320"/>
           </a:xfrm>
           <a:prstGeom prst="rect">
@@ -4799,7 +4846,7 @@
                 <a:ea typeface="Calibri" pitchFamily="34" charset="-122"/>
                 <a:cs typeface="Calibri" pitchFamily="34" charset="-120"/>
               </a:rPr>
-              <a:t>= 18 × start</a:t>
+              <a:t>= 9 × start</a:t>
             </a:r>
             <a:endParaRPr lang="en-US" sz="1400" dirty="0"/>
           </a:p>

</xml_diff>

<commit_message>
Blackjack: new turn order (first team once, second team twice, then alternate)
Order is L R R L R L R L (4 scans each) for whichever team plays first.
No-copy now means not the card your opponent played last. Status/pill show
"Turn k of 8" and "2nd in a row". Rules screen, slide 11, script, guide and
checklist updated.

Co-Authored-By: Claude Sonnet 5.5 <noreply@anthropic.com>
</commit_message>
<xml_diff>
--- a/DR_Overview.pptx
+++ b/DR_Overview.pptx
@@ -782,7 +782,7 @@
           <a:p>
             <a:r>
               <a:rPr lang="en-US" dirty="0"/>
-              <a:t>D hosts; A clicks cards, B referees, C collects Team Left votes. Split the room into Team Left and Team Right, each with a captain. Both teams start from the same grainy image; the ideal image is always on screen. Each round, a team plays a multiplier card on its own last scan, so cards chain (x6 then x1.5 = x9 of the start). The new image appears for both teams, so they compare; once anyone has played, the START image appears as a reference column. The first team's card is blocked for the second team that round. First pick alternates (the Random button decides round 1). Clocks: 30 seconds per turn (timeout means that team stands) and 3 minutes for the whole game (when it ends both teams stand). Up to 4 rounds or STAND; a team that stands is out, but the other team keeps playing all its remaining rounds, so standing early gives no advantage. The last image is the submission. Score = Quality x 2 minus Dose; quality is hidden until the reveal, dose is the bar. About 25 s per round. Then press Reveal and hand to slide 12.</a:t>
+              <a:t>D hosts; A clicks cards, B referees, C collects Team Left votes. Split the room into Team Left and Team Right, each with a captain. Both teams start from the same grainy image; the ideal image is always on screen. Each round, a team plays a multiplier card on its own last scan, so cards chain (x6 then x1.5 = x9 of the start). The new image appears for both teams, so they compare; once anyone has played, the START image appears as a reference column. The first team's card is blocked for the second team that round. The Random button decides who plays first; that team plays once, then the other team plays twice in a row (its trade for going second), then they alternate: L R R L R L R L, four scans each. Clocks: 30 seconds per turn (timeout means that team stands) and 3 minutes for the whole game (when it ends both teams stand). Up to 4 rounds or STAND; a team that stands is out, but the other team keeps playing all its remaining rounds, so standing early gives no advantage. The last image is the submission. Score = Quality x 2 minus Dose; quality is hidden until the reveal, dose is the bar. About 25 s per round. Then press Reveal and hand to slide 12.</a:t>
             </a:r>
             <a:endParaRPr lang="en-US" dirty="0"/>
           </a:p>
@@ -3710,7 +3710,7 @@
                 <a:ea typeface="Calibri" pitchFamily="34" charset="-122"/>
                 <a:cs typeface="Calibri" pitchFamily="34" charset="-120"/>
               </a:rPr>
-              <a:t>Each round: play a × card. It multiplies your last scan, so cards chain.</a:t>
+              <a:t>Each turn: play a × card. It multiplies your last scan, so cards chain.</a:t>
             </a:r>
             <a:endParaRPr lang="en-US" sz="1800" dirty="0"/>
           </a:p>
@@ -3794,7 +3794,7 @@
                 <a:ea typeface="Calibri" pitchFamily="34" charset="-122"/>
                 <a:cs typeface="Calibri" pitchFamily="34" charset="-120"/>
               </a:rPr>
-              <a:t>No copying: the first team’s card is blocked for the second.</a:t>
+              <a:t>Order: first team once, then the other twice in a row, then alternate (L R R L R L R L). No copying: not your opponent’s last card.</a:t>
             </a:r>
             <a:endParaRPr lang="en-US" sz="1800" dirty="0"/>
           </a:p>
@@ -3878,7 +3878,7 @@
                 <a:ea typeface="Calibri" pitchFamily="34" charset="-122"/>
                 <a:cs typeface="Calibri" pitchFamily="34" charset="-120"/>
               </a:rPr>
-              <a:t>Up to 4 rounds, or STAND (timeout = STAND). Last image counts.</a:t>
+              <a:t>4 scans each, or STAND (timeout = STAND). Last image counts.</a:t>
             </a:r>
             <a:endParaRPr lang="en-US" sz="1800" dirty="0"/>
           </a:p>

</xml_diff>